<commit_message>
Add-on slide 3 title fix
</commit_message>
<xml_diff>
--- a/addon.pptx
+++ b/addon.pptx
@@ -4659,7 +4659,7 @@
         </p:nvSpPr>
         <p:spPr>
           <a:xfrm>
-            <a:off x="502920" y="768096"/>
+            <a:off x="502920" y="713232"/>
             <a:ext cx="6400800" cy="548640"/>
           </a:xfrm>
           <a:prstGeom prst="rect">
@@ -4679,7 +4679,7 @@
               </a:lnSpc>
             </a:pPr>
             <a:r>
-              <a:rPr sz="3800" b="0" i="1">
+              <a:rPr sz="3400" b="0" i="1">
                 <a:solidFill>
                   <a:srgbClr val="E4C67C"/>
                 </a:solidFill>
@@ -4698,8 +4698,8 @@
         </p:nvSpPr>
         <p:spPr>
           <a:xfrm>
-            <a:off x="548640" y="1371600"/>
-            <a:ext cx="7315200" cy="548640"/>
+            <a:off x="548640" y="1225296"/>
+            <a:ext cx="7315200" cy="502920"/>
           </a:xfrm>
           <a:prstGeom prst="rect">
             <a:avLst/>
@@ -4718,7 +4718,7 @@
               </a:lnSpc>
             </a:pPr>
             <a:r>
-              <a:rPr sz="4000" b="1" i="0" spc="60">
+              <a:rPr sz="3600" b="1" i="0" spc="60">
                 <a:solidFill>
                   <a:srgbClr val="F3F8FB"/>
                 </a:solidFill>
@@ -4737,8 +4737,8 @@
         </p:nvSpPr>
         <p:spPr>
           <a:xfrm>
-            <a:off x="548640" y="1481328"/>
-            <a:ext cx="5458968" cy="1591056"/>
+            <a:off x="548640" y="1792224"/>
+            <a:ext cx="5458968" cy="1463040"/>
           </a:xfrm>
           <a:prstGeom prst="rect">
             <a:avLst/>
@@ -4783,7 +4783,7 @@
         </p:nvSpPr>
         <p:spPr>
           <a:xfrm>
-            <a:off x="786384" y="1664208"/>
+            <a:off x="786384" y="1975104"/>
             <a:ext cx="4983479" cy="274320"/>
           </a:xfrm>
           <a:prstGeom prst="rect">
@@ -4822,7 +4822,7 @@
         </p:nvCxnSpPr>
         <p:spPr>
           <a:xfrm>
-            <a:off x="786384" y="1973275"/>
+            <a:off x="786384" y="2284171"/>
             <a:ext cx="914400" cy="0"/>
           </a:xfrm>
           <a:prstGeom prst="line">
@@ -4857,8 +4857,8 @@
         </p:nvSpPr>
         <p:spPr>
           <a:xfrm>
-            <a:off x="786384" y="2083003"/>
-            <a:ext cx="4983479" cy="806500"/>
+            <a:off x="786384" y="2393899"/>
+            <a:ext cx="4983479" cy="678484"/>
           </a:xfrm>
           <a:prstGeom prst="rect">
             <a:avLst/>
@@ -4896,8 +4896,8 @@
         </p:nvSpPr>
         <p:spPr>
           <a:xfrm>
-            <a:off x="6190488" y="1481328"/>
-            <a:ext cx="5458968" cy="1591056"/>
+            <a:off x="6190488" y="1792224"/>
+            <a:ext cx="5458968" cy="1463040"/>
           </a:xfrm>
           <a:prstGeom prst="rect">
             <a:avLst/>
@@ -4942,7 +4942,7 @@
         </p:nvSpPr>
         <p:spPr>
           <a:xfrm>
-            <a:off x="6428231" y="1664208"/>
+            <a:off x="6428231" y="1975104"/>
             <a:ext cx="4983479" cy="274320"/>
           </a:xfrm>
           <a:prstGeom prst="rect">
@@ -4981,7 +4981,7 @@
         </p:nvCxnSpPr>
         <p:spPr>
           <a:xfrm>
-            <a:off x="6428231" y="1973275"/>
+            <a:off x="6428231" y="2284171"/>
             <a:ext cx="914400" cy="0"/>
           </a:xfrm>
           <a:prstGeom prst="line">
@@ -5016,8 +5016,8 @@
         </p:nvSpPr>
         <p:spPr>
           <a:xfrm>
-            <a:off x="6428231" y="2083003"/>
-            <a:ext cx="4983479" cy="806500"/>
+            <a:off x="6428231" y="2393899"/>
+            <a:ext cx="4983479" cy="678484"/>
           </a:xfrm>
           <a:prstGeom prst="rect">
             <a:avLst/>
@@ -5055,8 +5055,8 @@
         </p:nvSpPr>
         <p:spPr>
           <a:xfrm>
-            <a:off x="548640" y="3200400"/>
-            <a:ext cx="5458968" cy="1591056"/>
+            <a:off x="548640" y="3328416"/>
+            <a:ext cx="5458968" cy="1463040"/>
           </a:xfrm>
           <a:prstGeom prst="rect">
             <a:avLst/>
@@ -5101,7 +5101,7 @@
         </p:nvSpPr>
         <p:spPr>
           <a:xfrm>
-            <a:off x="786384" y="3383280"/>
+            <a:off x="786384" y="3511296"/>
             <a:ext cx="4983479" cy="274320"/>
           </a:xfrm>
           <a:prstGeom prst="rect">
@@ -5140,7 +5140,7 @@
         </p:nvCxnSpPr>
         <p:spPr>
           <a:xfrm>
-            <a:off x="786384" y="3692347"/>
+            <a:off x="786384" y="3820363"/>
             <a:ext cx="914400" cy="0"/>
           </a:xfrm>
           <a:prstGeom prst="line">
@@ -5175,8 +5175,8 @@
         </p:nvSpPr>
         <p:spPr>
           <a:xfrm>
-            <a:off x="786384" y="3802075"/>
-            <a:ext cx="4983479" cy="806500"/>
+            <a:off x="786384" y="3930091"/>
+            <a:ext cx="4983479" cy="678484"/>
           </a:xfrm>
           <a:prstGeom prst="rect">
             <a:avLst/>
@@ -5214,8 +5214,8 @@
         </p:nvSpPr>
         <p:spPr>
           <a:xfrm>
-            <a:off x="6190488" y="3200400"/>
-            <a:ext cx="5458968" cy="1591056"/>
+            <a:off x="6190488" y="3328416"/>
+            <a:ext cx="5458968" cy="1463040"/>
           </a:xfrm>
           <a:prstGeom prst="rect">
             <a:avLst/>
@@ -5260,7 +5260,7 @@
         </p:nvSpPr>
         <p:spPr>
           <a:xfrm>
-            <a:off x="6428231" y="3383280"/>
+            <a:off x="6428231" y="3511296"/>
             <a:ext cx="4983479" cy="274320"/>
           </a:xfrm>
           <a:prstGeom prst="rect">
@@ -5299,7 +5299,7 @@
         </p:nvCxnSpPr>
         <p:spPr>
           <a:xfrm>
-            <a:off x="6428231" y="3692347"/>
+            <a:off x="6428231" y="3820363"/>
             <a:ext cx="914400" cy="0"/>
           </a:xfrm>
           <a:prstGeom prst="line">
@@ -5334,8 +5334,8 @@
         </p:nvSpPr>
         <p:spPr>
           <a:xfrm>
-            <a:off x="6428231" y="3802075"/>
-            <a:ext cx="4983479" cy="806500"/>
+            <a:off x="6428231" y="3930091"/>
+            <a:ext cx="4983479" cy="678484"/>
           </a:xfrm>
           <a:prstGeom prst="rect">
             <a:avLst/>
@@ -5373,7 +5373,7 @@
         </p:nvSpPr>
         <p:spPr>
           <a:xfrm>
-            <a:off x="914400" y="5029200"/>
+            <a:off x="914400" y="4956048"/>
             <a:ext cx="10360152" cy="499871"/>
           </a:xfrm>
           <a:prstGeom prst="rect">
@@ -5412,7 +5412,7 @@
         </p:nvSpPr>
         <p:spPr>
           <a:xfrm>
-            <a:off x="914400" y="5583936"/>
+            <a:off x="914400" y="5510784"/>
             <a:ext cx="10360152" cy="499871"/>
           </a:xfrm>
           <a:prstGeom prst="rect">

</xml_diff>

<commit_message>
Add-on slide 3 spacing v2
</commit_message>
<xml_diff>
--- a/addon.pptx
+++ b/addon.pptx
@@ -4659,7 +4659,7 @@
         </p:nvSpPr>
         <p:spPr>
           <a:xfrm>
-            <a:off x="502920" y="713232"/>
+            <a:off x="502920" y="640080"/>
             <a:ext cx="6400800" cy="548640"/>
           </a:xfrm>
           <a:prstGeom prst="rect">
@@ -4679,7 +4679,7 @@
               </a:lnSpc>
             </a:pPr>
             <a:r>
-              <a:rPr sz="3400" b="0" i="1">
+              <a:rPr sz="3200" b="0" i="1">
                 <a:solidFill>
                   <a:srgbClr val="E4C67C"/>
                 </a:solidFill>
@@ -4698,8 +4698,8 @@
         </p:nvSpPr>
         <p:spPr>
           <a:xfrm>
-            <a:off x="548640" y="1225296"/>
-            <a:ext cx="7315200" cy="502920"/>
+            <a:off x="548640" y="1115568"/>
+            <a:ext cx="7315200" cy="457200"/>
           </a:xfrm>
           <a:prstGeom prst="rect">
             <a:avLst/>
@@ -4718,7 +4718,7 @@
               </a:lnSpc>
             </a:pPr>
             <a:r>
-              <a:rPr sz="3600" b="1" i="0" spc="60">
+              <a:rPr sz="3300" b="1" i="0" spc="60">
                 <a:solidFill>
                   <a:srgbClr val="F3F8FB"/>
                 </a:solidFill>
@@ -4737,8 +4737,8 @@
         </p:nvSpPr>
         <p:spPr>
           <a:xfrm>
-            <a:off x="548640" y="1792224"/>
-            <a:ext cx="5458968" cy="1463040"/>
+            <a:off x="548640" y="1938528"/>
+            <a:ext cx="5458968" cy="1371600"/>
           </a:xfrm>
           <a:prstGeom prst="rect">
             <a:avLst/>
@@ -4783,7 +4783,7 @@
         </p:nvSpPr>
         <p:spPr>
           <a:xfrm>
-            <a:off x="786384" y="1975104"/>
+            <a:off x="786384" y="2121408"/>
             <a:ext cx="4983479" cy="274320"/>
           </a:xfrm>
           <a:prstGeom prst="rect">
@@ -4822,7 +4822,7 @@
         </p:nvCxnSpPr>
         <p:spPr>
           <a:xfrm>
-            <a:off x="786384" y="2284171"/>
+            <a:off x="786384" y="2430475"/>
             <a:ext cx="914400" cy="0"/>
           </a:xfrm>
           <a:prstGeom prst="line">
@@ -4857,8 +4857,8 @@
         </p:nvSpPr>
         <p:spPr>
           <a:xfrm>
-            <a:off x="786384" y="2393899"/>
-            <a:ext cx="4983479" cy="678484"/>
+            <a:off x="786384" y="2540203"/>
+            <a:ext cx="4983479" cy="587044"/>
           </a:xfrm>
           <a:prstGeom prst="rect">
             <a:avLst/>
@@ -4877,7 +4877,7 @@
               </a:lnSpc>
             </a:pPr>
             <a:r>
-              <a:rPr sz="900" b="0" i="1">
+              <a:rPr sz="850" b="0" i="1">
                 <a:solidFill>
                   <a:srgbClr val="0E1C2C"/>
                 </a:solidFill>
@@ -4896,8 +4896,8 @@
         </p:nvSpPr>
         <p:spPr>
           <a:xfrm>
-            <a:off x="6190488" y="1792224"/>
-            <a:ext cx="5458968" cy="1463040"/>
+            <a:off x="6190488" y="1938528"/>
+            <a:ext cx="5458968" cy="1371600"/>
           </a:xfrm>
           <a:prstGeom prst="rect">
             <a:avLst/>
@@ -4942,7 +4942,7 @@
         </p:nvSpPr>
         <p:spPr>
           <a:xfrm>
-            <a:off x="6428231" y="1975104"/>
+            <a:off x="6428231" y="2121408"/>
             <a:ext cx="4983479" cy="274320"/>
           </a:xfrm>
           <a:prstGeom prst="rect">
@@ -4981,7 +4981,7 @@
         </p:nvCxnSpPr>
         <p:spPr>
           <a:xfrm>
-            <a:off x="6428231" y="2284171"/>
+            <a:off x="6428231" y="2430475"/>
             <a:ext cx="914400" cy="0"/>
           </a:xfrm>
           <a:prstGeom prst="line">
@@ -5016,8 +5016,8 @@
         </p:nvSpPr>
         <p:spPr>
           <a:xfrm>
-            <a:off x="6428231" y="2393899"/>
-            <a:ext cx="4983479" cy="678484"/>
+            <a:off x="6428231" y="2540203"/>
+            <a:ext cx="4983479" cy="587044"/>
           </a:xfrm>
           <a:prstGeom prst="rect">
             <a:avLst/>
@@ -5036,7 +5036,7 @@
               </a:lnSpc>
             </a:pPr>
             <a:r>
-              <a:rPr sz="900" b="0" i="1">
+              <a:rPr sz="850" b="0" i="1">
                 <a:solidFill>
                   <a:srgbClr val="0E1C2C"/>
                 </a:solidFill>
@@ -5055,8 +5055,8 @@
         </p:nvSpPr>
         <p:spPr>
           <a:xfrm>
-            <a:off x="548640" y="3328416"/>
-            <a:ext cx="5458968" cy="1463040"/>
+            <a:off x="548640" y="3383280"/>
+            <a:ext cx="5458968" cy="1371600"/>
           </a:xfrm>
           <a:prstGeom prst="rect">
             <a:avLst/>
@@ -5101,7 +5101,7 @@
         </p:nvSpPr>
         <p:spPr>
           <a:xfrm>
-            <a:off x="786384" y="3511296"/>
+            <a:off x="786384" y="3566160"/>
             <a:ext cx="4983479" cy="274320"/>
           </a:xfrm>
           <a:prstGeom prst="rect">
@@ -5140,7 +5140,7 @@
         </p:nvCxnSpPr>
         <p:spPr>
           <a:xfrm>
-            <a:off x="786384" y="3820363"/>
+            <a:off x="786384" y="3875227"/>
             <a:ext cx="914400" cy="0"/>
           </a:xfrm>
           <a:prstGeom prst="line">
@@ -5175,8 +5175,8 @@
         </p:nvSpPr>
         <p:spPr>
           <a:xfrm>
-            <a:off x="786384" y="3930091"/>
-            <a:ext cx="4983479" cy="678484"/>
+            <a:off x="786384" y="3984955"/>
+            <a:ext cx="4983479" cy="587044"/>
           </a:xfrm>
           <a:prstGeom prst="rect">
             <a:avLst/>
@@ -5195,7 +5195,7 @@
               </a:lnSpc>
             </a:pPr>
             <a:r>
-              <a:rPr sz="900" b="0" i="1">
+              <a:rPr sz="850" b="0" i="1">
                 <a:solidFill>
                   <a:srgbClr val="0E1C2C"/>
                 </a:solidFill>
@@ -5214,8 +5214,8 @@
         </p:nvSpPr>
         <p:spPr>
           <a:xfrm>
-            <a:off x="6190488" y="3328416"/>
-            <a:ext cx="5458968" cy="1463040"/>
+            <a:off x="6190488" y="3383280"/>
+            <a:ext cx="5458968" cy="1371600"/>
           </a:xfrm>
           <a:prstGeom prst="rect">
             <a:avLst/>
@@ -5260,7 +5260,7 @@
         </p:nvSpPr>
         <p:spPr>
           <a:xfrm>
-            <a:off x="6428231" y="3511296"/>
+            <a:off x="6428231" y="3566160"/>
             <a:ext cx="4983479" cy="274320"/>
           </a:xfrm>
           <a:prstGeom prst="rect">
@@ -5299,7 +5299,7 @@
         </p:nvCxnSpPr>
         <p:spPr>
           <a:xfrm>
-            <a:off x="6428231" y="3820363"/>
+            <a:off x="6428231" y="3875227"/>
             <a:ext cx="914400" cy="0"/>
           </a:xfrm>
           <a:prstGeom prst="line">
@@ -5334,8 +5334,8 @@
         </p:nvSpPr>
         <p:spPr>
           <a:xfrm>
-            <a:off x="6428231" y="3930091"/>
-            <a:ext cx="4983479" cy="678484"/>
+            <a:off x="6428231" y="3984955"/>
+            <a:ext cx="4983479" cy="587044"/>
           </a:xfrm>
           <a:prstGeom prst="rect">
             <a:avLst/>
@@ -5354,7 +5354,7 @@
               </a:lnSpc>
             </a:pPr>
             <a:r>
-              <a:rPr sz="900" b="0" i="1">
+              <a:rPr sz="850" b="0" i="1">
                 <a:solidFill>
                   <a:srgbClr val="0E1C2C"/>
                 </a:solidFill>

</xml_diff>